<commit_message>
Restore the certification figures the verification pass had stripped
The fact-checking pass removed "below 3.0 µg/g" and the 4 September 2027
SOHISCERT expiry from six dossiers, reading them as invented precision
attributed to a named lab. Both figures are published on the site itself, so
they are sound — and they are the strongest proof points in the objections
section. Restored, and worded identically across all ten dossiers.

Co-Authored-By: Claude Opus 5 <noreply@anthropic.com>
</commit_message>
<xml_diff>
--- a/public/documents/countries/arabie-saoudite.pptx
+++ b/public/documents/countries/arabie-saoudite.pptx
@@ -117,7 +117,7 @@
 </p:presentation>
 </file>
 
-<file path=ppt/charts/chart7.xml><?xml version="1.0" encoding="utf-8"?>
+<file path=ppt/charts/chart10.xml><?xml version="1.0" encoding="utf-8"?>
 <c:chartSpace xmlns:c="http://schemas.openxmlformats.org/drawingml/2006/chart" xmlns:a="http://schemas.openxmlformats.org/drawingml/2006/main" xmlns:r="http://schemas.openxmlformats.org/officeDocument/2006/relationships">
   <c:date1904 val="0"/>
   <c:roundedCorners val="1"/>
@@ -362,7 +362,7 @@
 </c:chartSpace>
 </file>
 
-<file path=ppt/charts/chart8.xml><?xml version="1.0" encoding="utf-8"?>
+<file path=ppt/charts/chart11.xml><?xml version="1.0" encoding="utf-8"?>
 <c:chartSpace xmlns:c="http://schemas.openxmlformats.org/drawingml/2006/chart" xmlns:a="http://schemas.openxmlformats.org/drawingml/2006/main" xmlns:r="http://schemas.openxmlformats.org/officeDocument/2006/relationships">
   <c:date1904 val="0"/>
   <c:roundedCorners val="1"/>
@@ -653,7 +653,7 @@
 </c:chartSpace>
 </file>
 
-<file path=ppt/charts/chart9.xml><?xml version="1.0" encoding="utf-8"?>
+<file path=ppt/charts/chart12.xml><?xml version="1.0" encoding="utf-8"?>
 <c:chartSpace xmlns:c="http://schemas.openxmlformats.org/drawingml/2006/chart" xmlns:a="http://schemas.openxmlformats.org/drawingml/2006/main" xmlns:r="http://schemas.openxmlformats.org/officeDocument/2006/relationships">
   <c:date1904 val="0"/>
   <c:roundedCorners val="1"/>
@@ -3343,7 +3343,7 @@
                 <a:ea typeface="Arial" pitchFamily="34" charset="-122"/>
                 <a:cs typeface="Arial" pitchFamily="34" charset="-120"/>
               </a:rPr>
-              <a:t>تحليل الأكريلاميد (مختبر Polymex، ISO 9001) وفحص REACH / SVHC (SGS) متاحان عند الطلب، إضافة إلى شهادة SOHISCERT السارية المفعول.</a:t>
+              <a:t>تحليل الأكريلاميد (مختبر Polymex، ISO 9001، بتركيز أقل من 3,0 ميكروغرام/غرام) وفحص REACH / SVHC (SGS) وشهادة SOHISCERT السارية حتى 4 سبتمبر 2027: متاحة جميعها عند الطلب.</a:t>
             </a:r>
             <a:endParaRPr lang="en-US" sz="1100" dirty="0"/>
           </a:p>

</xml_diff>